<commit_message>
remove defaults channel from env, vectorize figures, fix dilation in conv visualization, change export settings
</commit_message>
<xml_diff>
--- a/data/PCPT_fig_convolution.pptx
+++ b/data/PCPT_fig_convolution.pptx
@@ -241,7 +241,7 @@
           <a:p>
             <a:fld id="{973DF922-1DF1-4D42-AA74-D213C3C268B0}" type="datetimeFigureOut">
               <a:rPr lang="en-US" smtClean="0"/>
-              <a:t>7/28/2025</a:t>
+              <a:t>2/18/2026</a:t>
             </a:fld>
             <a:endParaRPr lang="en-US"/>
           </a:p>
@@ -283,7 +283,7 @@
           <a:p>
             <a:fld id="{EF908042-4F56-4D83-8BBB-4012AFA6CD85}" type="slidenum">
               <a:rPr lang="en-US" smtClean="0"/>
-              <a:t>‹#›</a:t>
+              <a:t>‹Nr.›</a:t>
             </a:fld>
             <a:endParaRPr lang="en-US"/>
           </a:p>
@@ -409,7 +409,7 @@
           <a:p>
             <a:fld id="{973DF922-1DF1-4D42-AA74-D213C3C268B0}" type="datetimeFigureOut">
               <a:rPr lang="en-US" smtClean="0"/>
-              <a:t>7/28/2025</a:t>
+              <a:t>2/18/2026</a:t>
             </a:fld>
             <a:endParaRPr lang="en-US"/>
           </a:p>
@@ -451,7 +451,7 @@
           <a:p>
             <a:fld id="{EF908042-4F56-4D83-8BBB-4012AFA6CD85}" type="slidenum">
               <a:rPr lang="en-US" smtClean="0"/>
-              <a:t>‹#›</a:t>
+              <a:t>‹Nr.›</a:t>
             </a:fld>
             <a:endParaRPr lang="en-US"/>
           </a:p>
@@ -587,7 +587,7 @@
           <a:p>
             <a:fld id="{973DF922-1DF1-4D42-AA74-D213C3C268B0}" type="datetimeFigureOut">
               <a:rPr lang="en-US" smtClean="0"/>
-              <a:t>7/28/2025</a:t>
+              <a:t>2/18/2026</a:t>
             </a:fld>
             <a:endParaRPr lang="en-US"/>
           </a:p>
@@ -629,7 +629,7 @@
           <a:p>
             <a:fld id="{EF908042-4F56-4D83-8BBB-4012AFA6CD85}" type="slidenum">
               <a:rPr lang="en-US" smtClean="0"/>
-              <a:t>‹#›</a:t>
+              <a:t>‹Nr.›</a:t>
             </a:fld>
             <a:endParaRPr lang="en-US"/>
           </a:p>
@@ -755,7 +755,7 @@
           <a:p>
             <a:fld id="{973DF922-1DF1-4D42-AA74-D213C3C268B0}" type="datetimeFigureOut">
               <a:rPr lang="en-US" smtClean="0"/>
-              <a:t>7/28/2025</a:t>
+              <a:t>2/18/2026</a:t>
             </a:fld>
             <a:endParaRPr lang="en-US"/>
           </a:p>
@@ -797,7 +797,7 @@
           <a:p>
             <a:fld id="{EF908042-4F56-4D83-8BBB-4012AFA6CD85}" type="slidenum">
               <a:rPr lang="en-US" smtClean="0"/>
-              <a:t>‹#›</a:t>
+              <a:t>‹Nr.›</a:t>
             </a:fld>
             <a:endParaRPr lang="en-US"/>
           </a:p>
@@ -1000,7 +1000,7 @@
           <a:p>
             <a:fld id="{973DF922-1DF1-4D42-AA74-D213C3C268B0}" type="datetimeFigureOut">
               <a:rPr lang="en-US" smtClean="0"/>
-              <a:t>7/28/2025</a:t>
+              <a:t>2/18/2026</a:t>
             </a:fld>
             <a:endParaRPr lang="en-US"/>
           </a:p>
@@ -1042,7 +1042,7 @@
           <a:p>
             <a:fld id="{EF908042-4F56-4D83-8BBB-4012AFA6CD85}" type="slidenum">
               <a:rPr lang="en-US" smtClean="0"/>
-              <a:t>‹#›</a:t>
+              <a:t>‹Nr.›</a:t>
             </a:fld>
             <a:endParaRPr lang="en-US"/>
           </a:p>
@@ -1229,7 +1229,7 @@
           <a:p>
             <a:fld id="{973DF922-1DF1-4D42-AA74-D213C3C268B0}" type="datetimeFigureOut">
               <a:rPr lang="en-US" smtClean="0"/>
-              <a:t>7/28/2025</a:t>
+              <a:t>2/18/2026</a:t>
             </a:fld>
             <a:endParaRPr lang="en-US"/>
           </a:p>
@@ -1271,7 +1271,7 @@
           <a:p>
             <a:fld id="{EF908042-4F56-4D83-8BBB-4012AFA6CD85}" type="slidenum">
               <a:rPr lang="en-US" smtClean="0"/>
-              <a:t>‹#›</a:t>
+              <a:t>‹Nr.›</a:t>
             </a:fld>
             <a:endParaRPr lang="en-US"/>
           </a:p>
@@ -1593,7 +1593,7 @@
           <a:p>
             <a:fld id="{973DF922-1DF1-4D42-AA74-D213C3C268B0}" type="datetimeFigureOut">
               <a:rPr lang="en-US" smtClean="0"/>
-              <a:t>7/28/2025</a:t>
+              <a:t>2/18/2026</a:t>
             </a:fld>
             <a:endParaRPr lang="en-US"/>
           </a:p>
@@ -1635,7 +1635,7 @@
           <a:p>
             <a:fld id="{EF908042-4F56-4D83-8BBB-4012AFA6CD85}" type="slidenum">
               <a:rPr lang="en-US" smtClean="0"/>
-              <a:t>‹#›</a:t>
+              <a:t>‹Nr.›</a:t>
             </a:fld>
             <a:endParaRPr lang="en-US"/>
           </a:p>
@@ -1710,7 +1710,7 @@
           <a:p>
             <a:fld id="{973DF922-1DF1-4D42-AA74-D213C3C268B0}" type="datetimeFigureOut">
               <a:rPr lang="en-US" smtClean="0"/>
-              <a:t>7/28/2025</a:t>
+              <a:t>2/18/2026</a:t>
             </a:fld>
             <a:endParaRPr lang="en-US"/>
           </a:p>
@@ -1752,7 +1752,7 @@
           <a:p>
             <a:fld id="{EF908042-4F56-4D83-8BBB-4012AFA6CD85}" type="slidenum">
               <a:rPr lang="en-US" smtClean="0"/>
-              <a:t>‹#›</a:t>
+              <a:t>‹Nr.›</a:t>
             </a:fld>
             <a:endParaRPr lang="en-US"/>
           </a:p>
@@ -1805,7 +1805,7 @@
           <a:p>
             <a:fld id="{973DF922-1DF1-4D42-AA74-D213C3C268B0}" type="datetimeFigureOut">
               <a:rPr lang="en-US" smtClean="0"/>
-              <a:t>7/28/2025</a:t>
+              <a:t>2/18/2026</a:t>
             </a:fld>
             <a:endParaRPr lang="en-US"/>
           </a:p>
@@ -1847,7 +1847,7 @@
           <a:p>
             <a:fld id="{EF908042-4F56-4D83-8BBB-4012AFA6CD85}" type="slidenum">
               <a:rPr lang="en-US" smtClean="0"/>
-              <a:t>‹#›</a:t>
+              <a:t>‹Nr.›</a:t>
             </a:fld>
             <a:endParaRPr lang="en-US"/>
           </a:p>
@@ -2080,7 +2080,7 @@
           <a:p>
             <a:fld id="{973DF922-1DF1-4D42-AA74-D213C3C268B0}" type="datetimeFigureOut">
               <a:rPr lang="en-US" smtClean="0"/>
-              <a:t>7/28/2025</a:t>
+              <a:t>2/18/2026</a:t>
             </a:fld>
             <a:endParaRPr lang="en-US"/>
           </a:p>
@@ -2122,7 +2122,7 @@
           <a:p>
             <a:fld id="{EF908042-4F56-4D83-8BBB-4012AFA6CD85}" type="slidenum">
               <a:rPr lang="en-US" smtClean="0"/>
-              <a:t>‹#›</a:t>
+              <a:t>‹Nr.›</a:t>
             </a:fld>
             <a:endParaRPr lang="en-US"/>
           </a:p>
@@ -2332,7 +2332,7 @@
           <a:p>
             <a:fld id="{973DF922-1DF1-4D42-AA74-D213C3C268B0}" type="datetimeFigureOut">
               <a:rPr lang="en-US" smtClean="0"/>
-              <a:t>7/28/2025</a:t>
+              <a:t>2/18/2026</a:t>
             </a:fld>
             <a:endParaRPr lang="en-US"/>
           </a:p>
@@ -2374,7 +2374,7 @@
           <a:p>
             <a:fld id="{EF908042-4F56-4D83-8BBB-4012AFA6CD85}" type="slidenum">
               <a:rPr lang="en-US" smtClean="0"/>
-              <a:t>‹#›</a:t>
+              <a:t>‹Nr.›</a:t>
             </a:fld>
             <a:endParaRPr lang="en-US"/>
           </a:p>
@@ -2543,7 +2543,7 @@
           <a:p>
             <a:fld id="{973DF922-1DF1-4D42-AA74-D213C3C268B0}" type="datetimeFigureOut">
               <a:rPr lang="en-US" smtClean="0"/>
-              <a:t>7/28/2025</a:t>
+              <a:t>2/18/2026</a:t>
             </a:fld>
             <a:endParaRPr lang="en-US"/>
           </a:p>
@@ -2621,7 +2621,7 @@
           <a:p>
             <a:fld id="{EF908042-4F56-4D83-8BBB-4012AFA6CD85}" type="slidenum">
               <a:rPr lang="en-US" smtClean="0"/>
-              <a:t>‹#›</a:t>
+              <a:t>‹Nr.›</a:t>
             </a:fld>
             <a:endParaRPr lang="en-US"/>
           </a:p>
@@ -3014,7 +3014,7 @@
                 <a:latin typeface="Arial" panose="020B0604020202020204" pitchFamily="34" charset="0"/>
                 <a:cs typeface="Arial" panose="020B0604020202020204" pitchFamily="34" charset="0"/>
               </a:rPr>
-              <a:t>K=3, P=0, S=1, D=0 </a:t>
+              <a:t>K=3, P=0, S=1, D=1 </a:t>
             </a:r>
           </a:p>
         </p:txBody>
@@ -6126,7 +6126,7 @@
                 <a:latin typeface="Arial" panose="020B0604020202020204" pitchFamily="34" charset="0"/>
                 <a:cs typeface="Arial" panose="020B0604020202020204" pitchFamily="34" charset="0"/>
               </a:rPr>
-              <a:t>K=3, P=0, S=1, D=0 </a:t>
+              <a:t>K=3, P=0, S=1, D=1 </a:t>
             </a:r>
           </a:p>
         </p:txBody>
@@ -6164,7 +6164,7 @@
                 <a:latin typeface="Arial" panose="020B0604020202020204" pitchFamily="34" charset="0"/>
                 <a:cs typeface="Arial" panose="020B0604020202020204" pitchFamily="34" charset="0"/>
               </a:rPr>
-              <a:t>K=3, P=1, S=1, D=0 </a:t>
+              <a:t>K=3, P=1, S=1, D=1 </a:t>
             </a:r>
           </a:p>
         </p:txBody>
@@ -6202,8 +6202,19 @@
                 <a:latin typeface="Arial" panose="020B0604020202020204" pitchFamily="34" charset="0"/>
                 <a:cs typeface="Arial" panose="020B0604020202020204" pitchFamily="34" charset="0"/>
               </a:rPr>
-              <a:t>K=3, P=1, S=2, D=0 </a:t>
-            </a:r>
+              <a:t>K=3, P=1, S=2, </a:t>
+            </a:r>
+            <a:r>
+              <a:rPr lang="en-US" sz="1600">
+                <a:latin typeface="Arial" panose="020B0604020202020204" pitchFamily="34" charset="0"/>
+                <a:cs typeface="Arial" panose="020B0604020202020204" pitchFamily="34" charset="0"/>
+              </a:rPr>
+              <a:t>D=1 </a:t>
+            </a:r>
+            <a:endParaRPr lang="en-US" sz="1600" dirty="0">
+              <a:latin typeface="Arial" panose="020B0604020202020204" pitchFamily="34" charset="0"/>
+              <a:cs typeface="Arial" panose="020B0604020202020204" pitchFamily="34" charset="0"/>
+            </a:endParaRPr>
           </a:p>
         </p:txBody>
       </p:sp>
@@ -6240,7 +6251,7 @@
                 <a:latin typeface="Arial" panose="020B0604020202020204" pitchFamily="34" charset="0"/>
                 <a:cs typeface="Arial" panose="020B0604020202020204" pitchFamily="34" charset="0"/>
               </a:rPr>
-              <a:t>K=3, P=1, S=1, D=1</a:t>
+              <a:t>K=3, P=1, S=1, D=2</a:t>
             </a:r>
           </a:p>
         </p:txBody>

</xml_diff>